<commit_message>
PPTX: real demo URLs
Co-Authored-By: Claude Sonnet 5.5 <noreply@anthropic.com>
Claude-Session: https://claude.ai/code/session_015uoh73XnFph6mW12UNs6m6
</commit_message>
<xml_diff>
--- a/deck/You_Yourself_Pitch.pptx
+++ b/deck/You_Yourself_Pitch.pptx
@@ -5001,7 +5001,7 @@
                 </a:solidFill>
                 <a:latin typeface="Calibri"/>
               </a:rPr>
-              <a:t>Open the Breadboard IDE → &lt;your-vercel-url&gt;/ide.html</a:t>
+              <a:t>Open the Breadboard IDE → you-yourself.vercel.app/ide.html</a:t>
             </a:r>
           </a:p>
         </p:txBody>
@@ -9982,7 +9982,7 @@
                 </a:solidFill>
                 <a:latin typeface="Calibri"/>
               </a:rPr>
-              <a:t>Open the live demo → &lt;your-vercel-url&gt;/#sim</a:t>
+              <a:t>Open the live demo → you-yourself.vercel.app/#sim</a:t>
             </a:r>
           </a:p>
         </p:txBody>

</xml_diff>

<commit_message>
Add 'You, Yourself' 3-minute film: renderer, score, narration, MP4
Animated film telling Senja's story (dramatised from the published case
report), the corollary-discharge science, the wearable's signal chain and
an imagined use scene, with English narration and Indonesian subtitles.

- film/: interactive player, canvas renderer, timeline, audio, MP4
- tools/film/: script (EDL), TTS narration + ASR check, original score and
  sound design, mixer, frame capture
- deck: Senja naming, captions corrected against the report, film link

Co-Authored-By: Claude Opus 5.5 <noreply@anthropic.com>
Claude-Session: https://claude.ai/code/session_015uoh73XnFph6mW12UNs6m6
</commit_message>
<xml_diff>
--- a/deck/You_Yourself_Pitch.pptx
+++ b/deck/You_Yourself_Pitch.pptx
@@ -4768,6 +4768,45 @@
           </a:p>
         </p:txBody>
       </p:sp>
+      <p:sp>
+        <p:nvSpPr>
+          <p:cNvPr id="6" name="TextBox 5"/>
+          <p:cNvSpPr txBox="1"/>
+          <p:nvPr/>
+        </p:nvSpPr>
+        <p:spPr>
+          <a:xfrm>
+            <a:off x="685800" y="5760720"/>
+            <a:ext cx="10058400" cy="457200"/>
+          </a:xfrm>
+          <a:prstGeom prst="rect">
+            <a:avLst/>
+          </a:prstGeom>
+          <a:noFill/>
+        </p:spPr>
+        <p:txBody>
+          <a:bodyPr wrap="square">
+            <a:spAutoFit/>
+          </a:bodyPr>
+          <a:lstStyle/>
+          <a:p>
+            <a:pPr>
+              <a:spcAft>
+                <a:spcPts val="800"/>
+              </a:spcAft>
+            </a:pPr>
+            <a:r>
+              <a:rPr sz="1600" b="1">
+                <a:solidFill>
+                  <a:srgbClr val="F5C04E"/>
+                </a:solidFill>
+                <a:latin typeface="Calibri"/>
+              </a:rPr>
+              <a:t>Watch the 3-minute film → you-yourself.vercel.app/film/</a:t>
+            </a:r>
+          </a:p>
+        </p:txBody>
+      </p:sp>
     </p:spTree>
   </p:cSld>
   <p:clrMapOvr>
@@ -7136,7 +7175,7 @@
                 </a:solidFill>
                 <a:latin typeface="Georgia"/>
               </a:rPr>
-              <a:t>Ny. G drew her way home.</a:t>
+              <a:t>Senja found her way home with crayons.</a:t>
             </a:r>
           </a:p>
         </p:txBody>
@@ -7230,7 +7269,46 @@
                 </a:solidFill>
                 <a:latin typeface="Georgia"/>
               </a:rPr>
-              <a:t>Try it now → the live demo.</a:t>
+              <a:t>Ayo pulang. Come home, to yourself.</a:t>
+            </a:r>
+          </a:p>
+        </p:txBody>
+      </p:sp>
+      <p:sp>
+        <p:nvSpPr>
+          <p:cNvPr id="6" name="TextBox 5"/>
+          <p:cNvSpPr txBox="1"/>
+          <p:nvPr/>
+        </p:nvSpPr>
+        <p:spPr>
+          <a:xfrm>
+            <a:off x="685800" y="5760720"/>
+            <a:ext cx="10058400" cy="457200"/>
+          </a:xfrm>
+          <a:prstGeom prst="rect">
+            <a:avLst/>
+          </a:prstGeom>
+          <a:noFill/>
+        </p:spPr>
+        <p:txBody>
+          <a:bodyPr wrap="square">
+            <a:spAutoFit/>
+          </a:bodyPr>
+          <a:lstStyle/>
+          <a:p>
+            <a:pPr>
+              <a:spcAft>
+                <a:spcPts val="800"/>
+              </a:spcAft>
+            </a:pPr>
+            <a:r>
+              <a:rPr sz="1600" b="1">
+                <a:solidFill>
+                  <a:srgbClr val="F5C04E"/>
+                </a:solidFill>
+                <a:latin typeface="Calibri"/>
+              </a:rPr>
+              <a:t>Open the live demo → you-yourself.vercel.app/#sim</a:t>
             </a:r>
           </a:p>
         </p:txBody>
@@ -7644,7 +7722,7 @@
                 </a:solidFill>
                 <a:latin typeface="Calibri"/>
               </a:rPr>
-              <a:t>Ny. G is 24. She is a low-paid honorary teacher at a junior-high school, and the eldest child of a family that no longer holds together.</a:t>
+              <a:t>Senja is 24. She is a low-paid honorary teacher at a junior-high school, and the eldest child of a family that no longer holds together.</a:t>
             </a:r>
           </a:p>
           <a:p>
@@ -7715,7 +7793,7 @@
                 </a:solidFill>
                 <a:latin typeface="Calibri"/>
               </a:rPr>
-              <a:t>Amelia, Rafiyah &amp; Widianti, “Penerapan intervensi menggambar pada pasien skizofrenia…”, SINERGI 2(2), 2025. Name anonymised in the report.</a:t>
+              <a:t>Amelia, Rafiyah &amp; Widianti, “Penerapan intervensi menggambar pada pasien skizofrenia…”, SINERGI 2(2), 2025. We call her Senja; the report calls her “Ny. G”.</a:t>
             </a:r>
           </a:p>
         </p:txBody>
@@ -8055,7 +8133,7 @@
         <p:spPr>
           <a:xfrm>
             <a:off x="685800" y="1554480"/>
-            <a:ext cx="3200400" cy="2400300"/>
+            <a:ext cx="3200400" cy="2262608"/>
           </a:xfrm>
           <a:prstGeom prst="rect">
             <a:avLst/>
@@ -8096,7 +8174,7 @@
                 </a:solidFill>
                 <a:latin typeface="Calibri"/>
               </a:rPr>
-              <a:t>Day 1 · a thick black whirlpool. She said it meant everything was piled up and tangled, and she didn’t know how to cope.</a:t>
+              <a:t>Day 1 · a tangled ball of black thread. She said it meant everything was piled up and tangled, and she didn’t know how to cope.</a:t>
             </a:r>
           </a:p>
         </p:txBody>
@@ -8118,7 +8196,7 @@
         <p:spPr>
           <a:xfrm>
             <a:off x="4434840" y="1554480"/>
-            <a:ext cx="3200400" cy="2400300"/>
+            <a:ext cx="3200400" cy="2262608"/>
           </a:xfrm>
           <a:prstGeom prst="rect">
             <a:avLst/>
@@ -8181,7 +8259,7 @@
         <p:spPr>
           <a:xfrm>
             <a:off x="8183879" y="1554480"/>
-            <a:ext cx="3200400" cy="2400300"/>
+            <a:ext cx="3200400" cy="2262608"/>
           </a:xfrm>
           <a:prstGeom prst="rect">
             <a:avLst/>
@@ -8222,7 +8300,7 @@
                 </a:solidFill>
                 <a:latin typeface="Calibri"/>
               </a:rPr>
-              <a:t>Day 3 · a mountain from her childhood, with both parents. She said she missed her family’s harmony.</a:t>
+              <a:t>Day 3 · the mountains she used to draw as a child, with her parents. She said she missed her family’s harmony.</a:t>
             </a:r>
           </a:p>
         </p:txBody>
@@ -8318,7 +8396,7 @@
                 </a:solidFill>
                 <a:latin typeface="Calibri"/>
               </a:rPr>
-              <a:t>Illustrations inspired by the report, not the patient’s own drawings. Counts from Table 1 of the report. One patient, no control group: encouraging, not proof.</a:t>
+              <a:t>Drawings recreated with the film’s crayon engine — not the patient’s own drawings. Counts from Table 1 of the report. One patient, no control group: encouraging, not proof.</a:t>
             </a:r>
           </a:p>
         </p:txBody>

</xml_diff>

<commit_message>
Film v2: cartoon Senja, fictional framing, no price
- Senja is now an animated cartoon character (toon.js): a real face that
  blinks, breathes and changes expression; cartoon family in the photo and
  the memory; the epilogue opens on Senja smiling at her drawing
- Story reframed as fiction ('Senja is fictional. The science is real.'):
  real-patient details removed; the drawing-therapy numbers are credited
  on screen to the 2025 case report as research evidence
- Price line and card removed; fourth promise card is the stress test
- Deck story slides made consistent; pycache untracked

Co-Authored-By: Claude Opus 5.5 <noreply@anthropic.com>
Claude-Session: https://claude.ai/code/session_015uoh73XnFph6mW12UNs6m6
</commit_message>
<xml_diff>
--- a/deck/You_Yourself_Pitch.pptx
+++ b/deck/You_Yourself_Pitch.pptx
@@ -139,7 +139,7 @@
               <c:strCache>
                 <c:ptCount val="1"/>
                 <c:pt idx="0">
-                  <c:v>Hallucination signs present (of 21 checked)</c:v>
+                  <c:v>A real case study: hallucination signs present (of 21 checked)</c:v>
                 </c:pt>
               </c:strCache>
             </c:strRef>
@@ -1022,7 +1022,7 @@
           <a:lstStyle/>
           <a:p>
             <a:r>
-              <a:t>End on the story, not the tech.</a:t>
+              <a:t>End on the story. Senja is fictional; the feeling is real.</a:t>
             </a:r>
           </a:p>
         </p:txBody>
@@ -1092,7 +1092,7 @@
           <a:lstStyle/>
           <a:p>
             <a:r>
-              <a:t>This is a published, anonymised nursing case report (Universitas Padjadjaran). Tell it as a story, but do not add details that are not in the paper.</a:t>
+              <a:t>Say it plainly: Senja is a fictional character; the science and the drawing-therapy data are real.</a:t>
             </a:r>
           </a:p>
         </p:txBody>
@@ -1162,7 +1162,7 @@
           <a:lstStyle/>
           <a:p>
             <a:r>
-              <a:t>Diagnosis: schizophrenia unspecified. Medication and standard coping (rebuking the voice, chatting, taking pills) were already in place; she said she still struggled to control the voices.</a:t>
+              <a:t>Fictional scene. Voices and shadows like these are common experiences in schizophrenia.</a:t>
             </a:r>
           </a:p>
         </p:txBody>
@@ -1232,7 +1232,7 @@
           <a:lstStyle/>
           <a:p>
             <a:r>
-              <a:t>Crayons were chosen on purpose because of her suicide history. Whispers fell from 4–5 to 2–3 a day by day 2. By day 3 only the shadow, occasionally, remained.</a:t>
+              <a:t>The 9 → 5 → 3 → 1 data is from the published case report, not from Senja (who is fictional).</a:t>
             </a:r>
           </a:p>
         </p:txBody>
@@ -7644,7 +7644,7 @@
                 </a:solidFill>
                 <a:latin typeface="Calibri"/>
               </a:rPr>
-              <a:t>A REAL STORY · WEST JAVA, JUNE 2024</a:t>
+              <a:t>MEET SENJA · A FICTIONAL STORY</a:t>
             </a:r>
           </a:p>
         </p:txBody>
@@ -7722,7 +7722,7 @@
                 </a:solidFill>
                 <a:latin typeface="Calibri"/>
               </a:rPr>
-              <a:t>Senja is 24. She is a low-paid honorary teacher at a junior-high school, and the eldest child of a family that no longer holds together.</a:t>
+              <a:t>Senja is a young teacher in West Java. She stays late every day, and her family leans on her.</a:t>
             </a:r>
           </a:p>
           <a:p>
@@ -7738,7 +7738,7 @@
                 </a:solidFill>
                 <a:latin typeface="Calibri"/>
               </a:rPr>
-              <a:t>Her parents divorced three years ago. Six months before she was admitted, her father died. Now she supports her mother and two younger siblings, and runs a school event on top of her classes.</a:t>
+              <a:t>Lessons, exams, a school event, the bills at home. Lately, it has all been too much.</a:t>
             </a:r>
           </a:p>
           <a:p>
@@ -7754,7 +7754,7 @@
                 </a:solidFill>
                 <a:latin typeface="Calibri"/>
               </a:rPr>
-              <a:t>The report notes she had nobody to share stories with or pour out her feelings to. She kept all of it inside.</a:t>
+              <a:t>And she has no one to tell.</a:t>
             </a:r>
           </a:p>
         </p:txBody>
@@ -7793,7 +7793,7 @@
                 </a:solidFill>
                 <a:latin typeface="Calibri"/>
               </a:rPr>
-              <a:t>Amelia, Rafiyah &amp; Widianti, “Penerapan intervensi menggambar pada pasien skizofrenia…”, SINERGI 2(2), 2025. We call her Senja; the report calls her “Ny. G”.</a:t>
+              <a:t>Senja is fictional. Her story reflects what many people who hear voices live with.</a:t>
             </a:r>
           </a:p>
         </p:txBody>
@@ -7975,7 +7975,7 @@
                 </a:solidFill>
                 <a:latin typeface="Calibri"/>
               </a:rPr>
-              <a:t>On 28 May 2024 her family brought her to a psychiatric hospital, in distress. She said she wanted to die.</a:t>
+              <a:t>Then the whispers begin. “Ayo pulang” — come home. Again, and again.</a:t>
             </a:r>
           </a:p>
           <a:p>
@@ -7991,7 +7991,7 @@
                 </a:solidFill>
                 <a:latin typeface="Calibri"/>
               </a:rPr>
-              <a:t>Days later, calmer, she described a black shadow that walked toward her, 5–7 times a day for 1–2 minutes. And whispers saying “ayo pulang”, 4–5 times a day, up to 5 minutes, usually too faint to make out.</a:t>
+              <a:t>A black shadow walks toward her. She covers her ears.</a:t>
             </a:r>
           </a:p>
           <a:p>
@@ -8007,7 +8007,7 @@
                 </a:solidFill>
                 <a:latin typeface="Calibri"/>
               </a:rPr>
-              <a:t>She pressed her hands over her ears. She talked to herself. She could not concentrate.</a:t>
+              <a:t>Her family brings her to a hospital, where her nurses try something simple: paper, and a box of crayons.</a:t>
             </a:r>
           </a:p>
         </p:txBody>
@@ -8357,7 +8357,7 @@
                 </a:solidFill>
                 <a:latin typeface="Calibri"/>
               </a:rPr>
-              <a:t>Hallucination signs present (of 21 checked)</a:t>
+              <a:t>A real case study: hallucination signs present (of 21 checked)</a:t>
             </a:r>
           </a:p>
         </p:txBody>
@@ -8396,7 +8396,7 @@
                 </a:solidFill>
                 <a:latin typeface="Calibri"/>
               </a:rPr>
-              <a:t>Drawings recreated with the film’s crayon engine — not the patient’s own drawings. Counts from Table 1 of the report. One patient, no control group: encouraging, not proof.</a:t>
+              <a:t>Drawings are illustrations from the film. The numbers come from a real 2025 case report (Amelia, Rafiyah &amp; Widianti, SINERGI 2(2)): one patient, no control group — encouraging, not proof.</a:t>
             </a:r>
           </a:p>
         </p:txBody>

</xml_diff>